<commit_message>
versión estable para hoy 02/02/2026
</commit_message>
<xml_diff>
--- a/app/templates/colegio_de_abogados_del_callao/plantilla_curso.pptx
+++ b/app/templates/colegio_de_abogados_del_callao/plantilla_curso.pptx
@@ -244,7 +244,7 @@
           <a:p>
             <a:fld id="{6B5BCF65-E86E-467A-B19A-9BBB66F1E598}" type="datetimeFigureOut">
               <a:rPr lang="es-PE" smtClean="0"/>
-              <a:t>28/01/2026</a:t>
+              <a:t>2/02/2026</a:t>
             </a:fld>
             <a:endParaRPr lang="es-PE"/>
           </a:p>
@@ -414,7 +414,7 @@
           <a:p>
             <a:fld id="{6B5BCF65-E86E-467A-B19A-9BBB66F1E598}" type="datetimeFigureOut">
               <a:rPr lang="es-PE" smtClean="0"/>
-              <a:t>28/01/2026</a:t>
+              <a:t>2/02/2026</a:t>
             </a:fld>
             <a:endParaRPr lang="es-PE"/>
           </a:p>
@@ -594,7 +594,7 @@
           <a:p>
             <a:fld id="{6B5BCF65-E86E-467A-B19A-9BBB66F1E598}" type="datetimeFigureOut">
               <a:rPr lang="es-PE" smtClean="0"/>
-              <a:t>28/01/2026</a:t>
+              <a:t>2/02/2026</a:t>
             </a:fld>
             <a:endParaRPr lang="es-PE"/>
           </a:p>
@@ -764,7 +764,7 @@
           <a:p>
             <a:fld id="{6B5BCF65-E86E-467A-B19A-9BBB66F1E598}" type="datetimeFigureOut">
               <a:rPr lang="es-PE" smtClean="0"/>
-              <a:t>28/01/2026</a:t>
+              <a:t>2/02/2026</a:t>
             </a:fld>
             <a:endParaRPr lang="es-PE"/>
           </a:p>
@@ -1008,7 +1008,7 @@
           <a:p>
             <a:fld id="{6B5BCF65-E86E-467A-B19A-9BBB66F1E598}" type="datetimeFigureOut">
               <a:rPr lang="es-PE" smtClean="0"/>
-              <a:t>28/01/2026</a:t>
+              <a:t>2/02/2026</a:t>
             </a:fld>
             <a:endParaRPr lang="es-PE"/>
           </a:p>
@@ -1240,7 +1240,7 @@
           <a:p>
             <a:fld id="{6B5BCF65-E86E-467A-B19A-9BBB66F1E598}" type="datetimeFigureOut">
               <a:rPr lang="es-PE" smtClean="0"/>
-              <a:t>28/01/2026</a:t>
+              <a:t>2/02/2026</a:t>
             </a:fld>
             <a:endParaRPr lang="es-PE"/>
           </a:p>
@@ -1607,7 +1607,7 @@
           <a:p>
             <a:fld id="{6B5BCF65-E86E-467A-B19A-9BBB66F1E598}" type="datetimeFigureOut">
               <a:rPr lang="es-PE" smtClean="0"/>
-              <a:t>28/01/2026</a:t>
+              <a:t>2/02/2026</a:t>
             </a:fld>
             <a:endParaRPr lang="es-PE"/>
           </a:p>
@@ -1725,7 +1725,7 @@
           <a:p>
             <a:fld id="{6B5BCF65-E86E-467A-B19A-9BBB66F1E598}" type="datetimeFigureOut">
               <a:rPr lang="es-PE" smtClean="0"/>
-              <a:t>28/01/2026</a:t>
+              <a:t>2/02/2026</a:t>
             </a:fld>
             <a:endParaRPr lang="es-PE"/>
           </a:p>
@@ -1820,7 +1820,7 @@
           <a:p>
             <a:fld id="{6B5BCF65-E86E-467A-B19A-9BBB66F1E598}" type="datetimeFigureOut">
               <a:rPr lang="es-PE" smtClean="0"/>
-              <a:t>28/01/2026</a:t>
+              <a:t>2/02/2026</a:t>
             </a:fld>
             <a:endParaRPr lang="es-PE"/>
           </a:p>
@@ -2097,7 +2097,7 @@
           <a:p>
             <a:fld id="{6B5BCF65-E86E-467A-B19A-9BBB66F1E598}" type="datetimeFigureOut">
               <a:rPr lang="es-PE" smtClean="0"/>
-              <a:t>28/01/2026</a:t>
+              <a:t>2/02/2026</a:t>
             </a:fld>
             <a:endParaRPr lang="es-PE"/>
           </a:p>
@@ -2354,7 +2354,7 @@
           <a:p>
             <a:fld id="{6B5BCF65-E86E-467A-B19A-9BBB66F1E598}" type="datetimeFigureOut">
               <a:rPr lang="es-PE" smtClean="0"/>
-              <a:t>28/01/2026</a:t>
+              <a:t>2/02/2026</a:t>
             </a:fld>
             <a:endParaRPr lang="es-PE"/>
           </a:p>
@@ -2567,7 +2567,7 @@
           <a:p>
             <a:fld id="{6B5BCF65-E86E-467A-B19A-9BBB66F1E598}" type="datetimeFigureOut">
               <a:rPr lang="es-PE" smtClean="0"/>
-              <a:t>28/01/2026</a:t>
+              <a:t>2/02/2026</a:t>
             </a:fld>
             <a:endParaRPr lang="es-PE"/>
           </a:p>

</xml_diff>

<commit_message>
cambios estables, códigos QR, código de estudiante, posicionamiento, todo listo para exportar a PDF
</commit_message>
<xml_diff>
--- a/app/templates/colegio_de_abogados_del_callao/plantilla_curso.pptx
+++ b/app/templates/colegio_de_abogados_del_callao/plantilla_curso.pptx
@@ -113,6 +113,122 @@
 </p:presentation>
 </file>
 
+<file path=ppt/revisionInfo.xml><?xml version="1.0" encoding="utf-8"?>
+<p1510:revInfo xmlns:a="http://schemas.openxmlformats.org/drawingml/2006/main" xmlns:r="http://schemas.openxmlformats.org/officeDocument/2006/relationships" xmlns:p1510="http://schemas.microsoft.com/office/powerpoint/2015/10/main">
+  <p1510:revLst>
+    <p1510:client id="{B1359E42-3EF3-4AF4-A794-31E08135502D}" v="3" dt="2026-03-05T19:07:28.063"/>
+  </p1510:revLst>
+</p1510:revInfo>
+</file>
+
+<file path=ppt/changesInfos/changesInfo1.xml><?xml version="1.0" encoding="utf-8"?>
+<pc:chgInfo xmlns:a="http://schemas.openxmlformats.org/drawingml/2006/main" xmlns:r="http://schemas.openxmlformats.org/officeDocument/2006/relationships" xmlns:ac="http://schemas.microsoft.com/office/drawing/2013/main/command" xmlns:pc="http://schemas.microsoft.com/office/powerpoint/2013/main/command">
+  <pc:docChgLst>
+    <pc:chgData name="Benjamín de Jesús Cueva Niño de Guzmán" userId="56da303013910523" providerId="LiveId" clId="{532B7A48-8887-4F62-9537-0BA1FAE83637}"/>
+    <pc:docChg chg="undo custSel modSld">
+      <pc:chgData name="Benjamín de Jesús Cueva Niño de Guzmán" userId="56da303013910523" providerId="LiveId" clId="{532B7A48-8887-4F62-9537-0BA1FAE83637}" dt="2026-03-05T19:07:28.063" v="47"/>
+      <pc:docMkLst>
+        <pc:docMk/>
+      </pc:docMkLst>
+      <pc:sldChg chg="addSp delSp modSp mod">
+        <pc:chgData name="Benjamín de Jesús Cueva Niño de Guzmán" userId="56da303013910523" providerId="LiveId" clId="{532B7A48-8887-4F62-9537-0BA1FAE83637}" dt="2026-03-05T18:21:57.445" v="43" actId="20577"/>
+        <pc:sldMkLst>
+          <pc:docMk/>
+          <pc:sldMk cId="1635965375" sldId="282"/>
+        </pc:sldMkLst>
+        <pc:spChg chg="add mod">
+          <ac:chgData name="Benjamín de Jesús Cueva Niño de Guzmán" userId="56da303013910523" providerId="LiveId" clId="{532B7A48-8887-4F62-9537-0BA1FAE83637}" dt="2026-03-05T18:21:57.445" v="43" actId="20577"/>
+          <ac:spMkLst>
+            <pc:docMk/>
+            <pc:sldMk cId="1635965375" sldId="282"/>
+            <ac:spMk id="4" creationId="{4D221194-97A3-DC72-499F-D799D459B54C}"/>
+          </ac:spMkLst>
+        </pc:spChg>
+        <pc:spChg chg="mod">
+          <ac:chgData name="Benjamín de Jesús Cueva Niño de Guzmán" userId="56da303013910523" providerId="LiveId" clId="{532B7A48-8887-4F62-9537-0BA1FAE83637}" dt="2026-03-05T18:10:40.812" v="32" actId="1035"/>
+          <ac:spMkLst>
+            <pc:docMk/>
+            <pc:sldMk cId="1635965375" sldId="282"/>
+            <ac:spMk id="15" creationId="{159C20CF-4F7D-CABE-6193-1BB5871BA92C}"/>
+          </ac:spMkLst>
+        </pc:spChg>
+        <pc:spChg chg="mod">
+          <ac:chgData name="Benjamín de Jesús Cueva Niño de Guzmán" userId="56da303013910523" providerId="LiveId" clId="{532B7A48-8887-4F62-9537-0BA1FAE83637}" dt="2026-03-05T18:10:40.812" v="32" actId="1035"/>
+          <ac:spMkLst>
+            <pc:docMk/>
+            <pc:sldMk cId="1635965375" sldId="282"/>
+            <ac:spMk id="16" creationId="{DBBC2EDB-EBF8-6457-ED53-A42DF6002084}"/>
+          </ac:spMkLst>
+        </pc:spChg>
+        <pc:spChg chg="del mod">
+          <ac:chgData name="Benjamín de Jesús Cueva Niño de Guzmán" userId="56da303013910523" providerId="LiveId" clId="{532B7A48-8887-4F62-9537-0BA1FAE83637}" dt="2026-03-05T18:10:28.940" v="28" actId="478"/>
+          <ac:spMkLst>
+            <pc:docMk/>
+            <pc:sldMk cId="1635965375" sldId="282"/>
+            <ac:spMk id="17" creationId="{D1A67D06-10F2-D0B5-2DE1-F3049EF0F799}"/>
+          </ac:spMkLst>
+        </pc:spChg>
+        <pc:spChg chg="del mod">
+          <ac:chgData name="Benjamín de Jesús Cueva Niño de Guzmán" userId="56da303013910523" providerId="LiveId" clId="{532B7A48-8887-4F62-9537-0BA1FAE83637}" dt="2026-03-05T18:10:28.940" v="28" actId="478"/>
+          <ac:spMkLst>
+            <pc:docMk/>
+            <pc:sldMk cId="1635965375" sldId="282"/>
+            <ac:spMk id="18" creationId="{C922BB6B-FC6C-B93A-97FB-548A5CAE37FC}"/>
+          </ac:spMkLst>
+        </pc:spChg>
+      </pc:sldChg>
+      <pc:sldChg chg="addSp delSp modSp mod">
+        <pc:chgData name="Benjamín de Jesús Cueva Niño de Guzmán" userId="56da303013910523" providerId="LiveId" clId="{532B7A48-8887-4F62-9537-0BA1FAE83637}" dt="2026-03-05T19:07:28.063" v="47"/>
+        <pc:sldMkLst>
+          <pc:docMk/>
+          <pc:sldMk cId="1692717128" sldId="283"/>
+        </pc:sldMkLst>
+        <pc:spChg chg="add mod">
+          <ac:chgData name="Benjamín de Jesús Cueva Niño de Guzmán" userId="56da303013910523" providerId="LiveId" clId="{532B7A48-8887-4F62-9537-0BA1FAE83637}" dt="2026-03-05T19:07:28.063" v="47"/>
+          <ac:spMkLst>
+            <pc:docMk/>
+            <pc:sldMk cId="1692717128" sldId="283"/>
+            <ac:spMk id="3" creationId="{30F4087D-AFB9-F358-EE89-78E5D8890726}"/>
+          </ac:spMkLst>
+        </pc:spChg>
+        <pc:spChg chg="del mod">
+          <ac:chgData name="Benjamín de Jesús Cueva Niño de Guzmán" userId="56da303013910523" providerId="LiveId" clId="{532B7A48-8887-4F62-9537-0BA1FAE83637}" dt="2026-03-05T18:22:04.740" v="44" actId="478"/>
+          <ac:spMkLst>
+            <pc:docMk/>
+            <pc:sldMk cId="1692717128" sldId="283"/>
+            <ac:spMk id="3" creationId="{73FC219E-6E54-02C6-2D68-ED6FE3FBB5EC}"/>
+          </ac:spMkLst>
+        </pc:spChg>
+        <pc:spChg chg="add mod">
+          <ac:chgData name="Benjamín de Jesús Cueva Niño de Guzmán" userId="56da303013910523" providerId="LiveId" clId="{532B7A48-8887-4F62-9537-0BA1FAE83637}" dt="2026-03-05T18:22:07.323" v="45"/>
+          <ac:spMkLst>
+            <pc:docMk/>
+            <pc:sldMk cId="1692717128" sldId="283"/>
+            <ac:spMk id="4" creationId="{C17EA1AD-01FF-52C7-D27A-E9BADDA3B15C}"/>
+          </ac:spMkLst>
+        </pc:spChg>
+        <pc:spChg chg="del">
+          <ac:chgData name="Benjamín de Jesús Cueva Niño de Guzmán" userId="56da303013910523" providerId="LiveId" clId="{532B7A48-8887-4F62-9537-0BA1FAE83637}" dt="2026-03-05T19:07:27.780" v="46" actId="478"/>
+          <ac:spMkLst>
+            <pc:docMk/>
+            <pc:sldMk cId="1692717128" sldId="283"/>
+            <ac:spMk id="21" creationId="{EA23FF2C-CCB1-4E12-6246-321FF9E9AE06}"/>
+          </ac:spMkLst>
+        </pc:spChg>
+        <pc:graphicFrameChg chg="modGraphic">
+          <ac:chgData name="Benjamín de Jesús Cueva Niño de Guzmán" userId="56da303013910523" providerId="LiveId" clId="{532B7A48-8887-4F62-9537-0BA1FAE83637}" dt="2026-03-05T18:11:10.787" v="38" actId="404"/>
+          <ac:graphicFrameMkLst>
+            <pc:docMk/>
+            <pc:sldMk cId="1692717128" sldId="283"/>
+            <ac:graphicFrameMk id="25" creationId="{2BEFD275-6BE4-1317-B22B-C737F9F62243}"/>
+          </ac:graphicFrameMkLst>
+        </pc:graphicFrameChg>
+      </pc:sldChg>
+    </pc:docChg>
+  </pc:docChgLst>
+</pc:chgInfo>
+</file>
+
 <file path=ppt/slideLayouts/slideLayout1.xml><?xml version="1.0" encoding="utf-8"?>
 <p:sldLayout xmlns:a="http://schemas.openxmlformats.org/drawingml/2006/main" xmlns:r="http://schemas.openxmlformats.org/officeDocument/2006/relationships" xmlns:p="http://schemas.openxmlformats.org/presentationml/2006/main" type="title" preserve="1">
   <p:cSld name="Diapositiva de título">
@@ -244,7 +360,7 @@
           <a:p>
             <a:fld id="{6B5BCF65-E86E-467A-B19A-9BBB66F1E598}" type="datetimeFigureOut">
               <a:rPr lang="es-PE" smtClean="0"/>
-              <a:t>2/02/2026</a:t>
+              <a:t>5/03/2026</a:t>
             </a:fld>
             <a:endParaRPr lang="es-PE"/>
           </a:p>
@@ -414,7 +530,7 @@
           <a:p>
             <a:fld id="{6B5BCF65-E86E-467A-B19A-9BBB66F1E598}" type="datetimeFigureOut">
               <a:rPr lang="es-PE" smtClean="0"/>
-              <a:t>2/02/2026</a:t>
+              <a:t>5/03/2026</a:t>
             </a:fld>
             <a:endParaRPr lang="es-PE"/>
           </a:p>
@@ -594,7 +710,7 @@
           <a:p>
             <a:fld id="{6B5BCF65-E86E-467A-B19A-9BBB66F1E598}" type="datetimeFigureOut">
               <a:rPr lang="es-PE" smtClean="0"/>
-              <a:t>2/02/2026</a:t>
+              <a:t>5/03/2026</a:t>
             </a:fld>
             <a:endParaRPr lang="es-PE"/>
           </a:p>
@@ -764,7 +880,7 @@
           <a:p>
             <a:fld id="{6B5BCF65-E86E-467A-B19A-9BBB66F1E598}" type="datetimeFigureOut">
               <a:rPr lang="es-PE" smtClean="0"/>
-              <a:t>2/02/2026</a:t>
+              <a:t>5/03/2026</a:t>
             </a:fld>
             <a:endParaRPr lang="es-PE"/>
           </a:p>
@@ -1008,7 +1124,7 @@
           <a:p>
             <a:fld id="{6B5BCF65-E86E-467A-B19A-9BBB66F1E598}" type="datetimeFigureOut">
               <a:rPr lang="es-PE" smtClean="0"/>
-              <a:t>2/02/2026</a:t>
+              <a:t>5/03/2026</a:t>
             </a:fld>
             <a:endParaRPr lang="es-PE"/>
           </a:p>
@@ -1240,7 +1356,7 @@
           <a:p>
             <a:fld id="{6B5BCF65-E86E-467A-B19A-9BBB66F1E598}" type="datetimeFigureOut">
               <a:rPr lang="es-PE" smtClean="0"/>
-              <a:t>2/02/2026</a:t>
+              <a:t>5/03/2026</a:t>
             </a:fld>
             <a:endParaRPr lang="es-PE"/>
           </a:p>
@@ -1607,7 +1723,7 @@
           <a:p>
             <a:fld id="{6B5BCF65-E86E-467A-B19A-9BBB66F1E598}" type="datetimeFigureOut">
               <a:rPr lang="es-PE" smtClean="0"/>
-              <a:t>2/02/2026</a:t>
+              <a:t>5/03/2026</a:t>
             </a:fld>
             <a:endParaRPr lang="es-PE"/>
           </a:p>
@@ -1725,7 +1841,7 @@
           <a:p>
             <a:fld id="{6B5BCF65-E86E-467A-B19A-9BBB66F1E598}" type="datetimeFigureOut">
               <a:rPr lang="es-PE" smtClean="0"/>
-              <a:t>2/02/2026</a:t>
+              <a:t>5/03/2026</a:t>
             </a:fld>
             <a:endParaRPr lang="es-PE"/>
           </a:p>
@@ -1820,7 +1936,7 @@
           <a:p>
             <a:fld id="{6B5BCF65-E86E-467A-B19A-9BBB66F1E598}" type="datetimeFigureOut">
               <a:rPr lang="es-PE" smtClean="0"/>
-              <a:t>2/02/2026</a:t>
+              <a:t>5/03/2026</a:t>
             </a:fld>
             <a:endParaRPr lang="es-PE"/>
           </a:p>
@@ -2097,7 +2213,7 @@
           <a:p>
             <a:fld id="{6B5BCF65-E86E-467A-B19A-9BBB66F1E598}" type="datetimeFigureOut">
               <a:rPr lang="es-PE" smtClean="0"/>
-              <a:t>2/02/2026</a:t>
+              <a:t>5/03/2026</a:t>
             </a:fld>
             <a:endParaRPr lang="es-PE"/>
           </a:p>
@@ -2354,7 +2470,7 @@
           <a:p>
             <a:fld id="{6B5BCF65-E86E-467A-B19A-9BBB66F1E598}" type="datetimeFigureOut">
               <a:rPr lang="es-PE" smtClean="0"/>
-              <a:t>2/02/2026</a:t>
+              <a:t>5/03/2026</a:t>
             </a:fld>
             <a:endParaRPr lang="es-PE"/>
           </a:p>
@@ -2567,7 +2683,7 @@
           <a:p>
             <a:fld id="{6B5BCF65-E86E-467A-B19A-9BBB66F1E598}" type="datetimeFigureOut">
               <a:rPr lang="es-PE" smtClean="0"/>
-              <a:t>2/02/2026</a:t>
+              <a:t>5/03/2026</a:t>
             </a:fld>
             <a:endParaRPr lang="es-PE"/>
           </a:p>
@@ -3117,7 +3233,7 @@
         </p:nvSpPr>
         <p:spPr>
           <a:xfrm>
-            <a:off x="4252904" y="1305575"/>
+            <a:off x="4252904" y="1277582"/>
             <a:ext cx="1400192" cy="369332"/>
           </a:xfrm>
           <a:prstGeom prst="rect">
@@ -3155,7 +3271,7 @@
         </p:nvSpPr>
         <p:spPr>
           <a:xfrm>
-            <a:off x="2493032" y="1544202"/>
+            <a:off x="2493032" y="1506878"/>
             <a:ext cx="4919937" cy="523220"/>
           </a:xfrm>
           <a:prstGeom prst="rect">
@@ -3175,128 +3291,6 @@
                 <a:latin typeface="Britannic Bold" panose="020B0903060703020204" pitchFamily="34" charset="0"/>
               </a:rPr>
               <a:t>{{NOMBRES}} {{APELLIDOS}}</a:t>
-            </a:r>
-          </a:p>
-        </p:txBody>
-      </p:sp>
-      <p:sp>
-        <p:nvSpPr>
-          <p:cNvPr id="17" name="CuadroTexto 16">
-            <a:extLst>
-              <a:ext uri="{FF2B5EF4-FFF2-40B4-BE49-F238E27FC236}">
-                <a16:creationId xmlns:a16="http://schemas.microsoft.com/office/drawing/2014/main" id="{D1A67D06-10F2-D0B5-2DE1-F3049EF0F799}"/>
-              </a:ext>
-            </a:extLst>
-          </p:cNvPr>
-          <p:cNvSpPr txBox="1"/>
-          <p:nvPr/>
-        </p:nvSpPr>
-        <p:spPr>
-          <a:xfrm>
-            <a:off x="-77961" y="1955637"/>
-            <a:ext cx="10061922" cy="1908215"/>
-          </a:xfrm>
-          <a:prstGeom prst="rect">
-            <a:avLst/>
-          </a:prstGeom>
-          <a:noFill/>
-        </p:spPr>
-        <p:txBody>
-          <a:bodyPr wrap="none" rtlCol="0">
-            <a:spAutoFit/>
-          </a:bodyPr>
-          <a:lstStyle/>
-          <a:p>
-            <a:pPr algn="ctr"/>
-            <a:r>
-              <a:rPr lang="es-PE" b="1" dirty="0"/>
-              <a:t>Por haber culminado satisfactoriamente el CURSO en :</a:t>
-            </a:r>
-            <a:endParaRPr lang="es-PE" sz="600" b="1" dirty="0"/>
-          </a:p>
-          <a:p>
-            <a:pPr algn="ctr"/>
-            <a:r>
-              <a:rPr lang="es-PE" sz="2800" dirty="0">
-                <a:latin typeface="Britannic Bold" panose="020B0903060703020204" pitchFamily="34" charset="0"/>
-              </a:rPr>
-              <a:t>“</a:t>
-            </a:r>
-            <a:r>
-              <a:rPr lang="es-ES" sz="2800" dirty="0">
-                <a:latin typeface="Britannic Bold" panose="020B0903060703020204" pitchFamily="34" charset="0"/>
-              </a:rPr>
-              <a:t>{{TEMA_DIPLOMADO}}</a:t>
-            </a:r>
-            <a:r>
-              <a:rPr lang="es-PE" sz="2800" dirty="0">
-                <a:latin typeface="Britannic Bold" panose="020B0903060703020204" pitchFamily="34" charset="0"/>
-              </a:rPr>
-              <a:t>”</a:t>
-            </a:r>
-          </a:p>
-          <a:p>
-            <a:pPr algn="ctr"/>
-            <a:r>
-              <a:rPr lang="es-PE" b="1" dirty="0"/>
-              <a:t>Realizado del {{FECHA_INICIO}} al {{FECHA_FIN}}, con una</a:t>
-            </a:r>
-          </a:p>
-          <a:p>
-            <a:pPr algn="ctr"/>
-            <a:r>
-              <a:rPr lang="es-PE" b="1" dirty="0"/>
-              <a:t>duración de {{HORAS_ACADEMICAS}} horas lectivas y {{CREDITOS_ACADEMICOS}} créditos académicos.</a:t>
-            </a:r>
-          </a:p>
-          <a:p>
-            <a:pPr algn="ctr"/>
-            <a:r>
-              <a:rPr lang="es-PE" b="1" dirty="0"/>
-              <a:t>Por tanto, se expide el presente Certificado, otorgándole los</a:t>
-            </a:r>
-          </a:p>
-          <a:p>
-            <a:pPr algn="ctr"/>
-            <a:r>
-              <a:rPr lang="es-PE" b="1" dirty="0"/>
-              <a:t>privilegios y consideraciones que le corresponden.</a:t>
-            </a:r>
-          </a:p>
-        </p:txBody>
-      </p:sp>
-      <p:sp>
-        <p:nvSpPr>
-          <p:cNvPr id="18" name="CuadroTexto 17">
-            <a:extLst>
-              <a:ext uri="{FF2B5EF4-FFF2-40B4-BE49-F238E27FC236}">
-                <a16:creationId xmlns:a16="http://schemas.microsoft.com/office/drawing/2014/main" id="{C922BB6B-FC6C-B93A-97FB-548A5CAE37FC}"/>
-              </a:ext>
-            </a:extLst>
-          </p:cNvPr>
-          <p:cNvSpPr txBox="1"/>
-          <p:nvPr/>
-        </p:nvSpPr>
-        <p:spPr>
-          <a:xfrm>
-            <a:off x="5888340" y="4292258"/>
-            <a:ext cx="3629904" cy="369332"/>
-          </a:xfrm>
-          <a:prstGeom prst="rect">
-            <a:avLst/>
-          </a:prstGeom>
-          <a:noFill/>
-        </p:spPr>
-        <p:txBody>
-          <a:bodyPr wrap="none" rtlCol="0">
-            <a:spAutoFit/>
-          </a:bodyPr>
-          <a:lstStyle/>
-          <a:p>
-            <a:pPr algn="r"/>
-            <a:r>
-              <a:rPr lang="es-PE" b="1" dirty="0"/>
-              <a:t>Trujillo, {{FECHA_EMISION_LARGA}}</a:t>
             </a:r>
           </a:p>
         </p:txBody>
@@ -3836,6 +3830,91 @@
           </a:prstGeom>
         </p:spPr>
       </p:pic>
+      <p:sp>
+        <p:nvSpPr>
+          <p:cNvPr id="4" name="CuadroTexto 3">
+            <a:extLst>
+              <a:ext uri="{FF2B5EF4-FFF2-40B4-BE49-F238E27FC236}">
+                <a16:creationId xmlns:a16="http://schemas.microsoft.com/office/drawing/2014/main" id="{4D221194-97A3-DC72-499F-D799D459B54C}"/>
+              </a:ext>
+            </a:extLst>
+          </p:cNvPr>
+          <p:cNvSpPr txBox="1"/>
+          <p:nvPr/>
+        </p:nvSpPr>
+        <p:spPr>
+          <a:xfrm>
+            <a:off x="380775" y="1915576"/>
+            <a:ext cx="9144451" cy="2523768"/>
+          </a:xfrm>
+          <a:prstGeom prst="rect">
+            <a:avLst/>
+          </a:prstGeom>
+          <a:noFill/>
+        </p:spPr>
+        <p:txBody>
+          <a:bodyPr wrap="square" rtlCol="0" anchor="t" anchorCtr="1">
+            <a:spAutoFit/>
+          </a:bodyPr>
+          <a:lstStyle/>
+          <a:p>
+            <a:pPr algn="ctr"/>
+            <a:r>
+              <a:rPr lang="es-PE" b="1" dirty="0"/>
+              <a:t>Por haber culminado satisfactoriamente el CURSO en:</a:t>
+            </a:r>
+            <a:endParaRPr lang="es-PE" sz="600" b="1" dirty="0"/>
+          </a:p>
+          <a:p>
+            <a:pPr algn="ctr"/>
+            <a:r>
+              <a:rPr lang="es-PE" sz="2800" dirty="0">
+                <a:latin typeface="Britannic Bold" panose="020B0903060703020204" pitchFamily="34" charset="0"/>
+              </a:rPr>
+              <a:t>“{{TEMA_DIPLOMADO}}”</a:t>
+            </a:r>
+          </a:p>
+          <a:p>
+            <a:pPr algn="ctr"/>
+            <a:r>
+              <a:rPr lang="es-PE" b="1" dirty="0"/>
+              <a:t>Realizado del {{FECHA_INICIO}} al {{FECHA_FIN}}, con una</a:t>
+            </a:r>
+          </a:p>
+          <a:p>
+            <a:pPr algn="ctr"/>
+            <a:r>
+              <a:rPr lang="es-PE" b="1" dirty="0"/>
+              <a:t>duración de {{HORAS_ACADEMICAS}} horas lectivas y {{CREDITOS_ACADEMICOS}} créditos Académicos.</a:t>
+            </a:r>
+          </a:p>
+          <a:p>
+            <a:pPr algn="ctr"/>
+            <a:r>
+              <a:rPr lang="es-PE" b="1" dirty="0"/>
+              <a:t>Por tanto, se expide el presente Certificado, otorgándole los</a:t>
+            </a:r>
+          </a:p>
+          <a:p>
+            <a:pPr algn="ctr"/>
+            <a:r>
+              <a:rPr lang="es-PE" b="1" dirty="0"/>
+              <a:t>privilegios y consideraciones que le corresponden.</a:t>
+            </a:r>
+          </a:p>
+          <a:p>
+            <a:pPr algn="ctr"/>
+            <a:endParaRPr lang="es-PE" sz="400" b="1" dirty="0"/>
+          </a:p>
+          <a:p>
+            <a:pPr algn="r"/>
+            <a:r>
+              <a:rPr lang="es-PE" b="1" dirty="0"/>
+              <a:t>Trujillo, {{FECHA_EMISION_LARGA}}</a:t>
+            </a:r>
+          </a:p>
+        </p:txBody>
+      </p:sp>
     </p:spTree>
     <p:extLst>
       <p:ext uri="{BB962C8B-B14F-4D97-AF65-F5344CB8AC3E}">
@@ -4308,67 +4387,6 @@
           </p:txBody>
         </p:sp>
       </p:grpSp>
-      <p:sp>
-        <p:nvSpPr>
-          <p:cNvPr id="21" name="Rectángulo 20">
-            <a:extLst>
-              <a:ext uri="{FF2B5EF4-FFF2-40B4-BE49-F238E27FC236}">
-                <a16:creationId xmlns:a16="http://schemas.microsoft.com/office/drawing/2014/main" id="{EA23FF2C-CCB1-4E12-6246-321FF9E9AE06}"/>
-              </a:ext>
-            </a:extLst>
-          </p:cNvPr>
-          <p:cNvSpPr/>
-          <p:nvPr/>
-        </p:nvSpPr>
-        <p:spPr>
-          <a:xfrm>
-            <a:off x="717736" y="5737281"/>
-            <a:ext cx="2130198" cy="366767"/>
-          </a:xfrm>
-          <a:prstGeom prst="rect">
-            <a:avLst/>
-          </a:prstGeom>
-        </p:spPr>
-        <p:txBody>
-          <a:bodyPr wrap="square">
-            <a:spAutoFit/>
-          </a:bodyPr>
-          <a:lstStyle/>
-          <a:p>
-            <a:pPr lvl="0" algn="ctr">
-              <a:spcBef>
-                <a:spcPts val="59"/>
-              </a:spcBef>
-            </a:pPr>
-            <a:r>
-              <a:rPr lang="es-PE" sz="900" dirty="0">
-                <a:solidFill>
-                  <a:prstClr val="black"/>
-                </a:solidFill>
-                <a:latin typeface="Times New Roman" panose="02020603050405020304" pitchFamily="18" charset="0"/>
-                <a:ea typeface="Cambria Math" panose="02040503050406030204" pitchFamily="18" charset="0"/>
-                <a:cs typeface="Times New Roman" panose="02020603050405020304" pitchFamily="18" charset="0"/>
-              </a:rPr>
-              <a:t>CÓDIGO ESTUDIANTE:</a:t>
-            </a:r>
-          </a:p>
-          <a:p>
-            <a:pPr lvl="0" algn="ctr">
-              <a:spcBef>
-                <a:spcPts val="59"/>
-              </a:spcBef>
-            </a:pPr>
-            <a:endParaRPr lang="en-US" sz="800" b="1" dirty="0">
-              <a:solidFill>
-                <a:prstClr val="black"/>
-              </a:solidFill>
-              <a:latin typeface="Times New Roman" panose="02020603050405020304" pitchFamily="18" charset="0"/>
-              <a:ea typeface="Cambria Math" panose="02040503050406030204" pitchFamily="18" charset="0"/>
-              <a:cs typeface="Times New Roman" panose="02020603050405020304" pitchFamily="18" charset="0"/>
-            </a:endParaRPr>
-          </a:p>
-        </p:txBody>
-      </p:sp>
       <p:graphicFrame>
         <p:nvGraphicFramePr>
           <p:cNvPr id="23" name="Tabla 22">
@@ -4490,7 +4508,7 @@
           <p:nvPr>
             <p:extLst>
               <p:ext uri="{D42A27DB-BD31-4B8C-83A1-F6EECF244321}">
-                <p14:modId xmlns:p14="http://schemas.microsoft.com/office/powerpoint/2010/main" val="2915525168"/>
+                <p14:modId xmlns:p14="http://schemas.microsoft.com/office/powerpoint/2010/main" val="1378832549"/>
               </p:ext>
             </p:extLst>
           </p:nvPr>
@@ -4529,14 +4547,14 @@
                     <a:p>
                       <a:pPr algn="ctr"/>
                       <a:r>
-                        <a:rPr lang="es-PE" sz="1150" b="0" dirty="0"/>
+                        <a:rPr lang="es-PE" sz="1120" b="0" dirty="0"/>
                         <a:t>MÓDULO</a:t>
                       </a:r>
                       <a:r>
-                        <a:rPr lang="es-PE" sz="1150" b="0" baseline="0" dirty="0"/>
+                        <a:rPr lang="es-PE" sz="1120" b="0" baseline="0" dirty="0"/>
                         <a:t> I</a:t>
                       </a:r>
-                      <a:endParaRPr lang="en-US" sz="1150" b="0" dirty="0">
+                      <a:endParaRPr lang="en-US" sz="1120" b="0" dirty="0">
                         <a:solidFill>
                           <a:schemeClr val="tx1"/>
                         </a:solidFill>
@@ -4552,7 +4570,7 @@
                     <a:p>
                       <a:pPr algn="ctr"/>
                       <a:r>
-                        <a:rPr lang="es-ES" sz="1150" b="0" i="0" dirty="0"/>
+                        <a:rPr lang="es-ES" sz="1000" b="0" i="0" dirty="0"/>
                         <a:t>{{MODULO_1}}</a:t>
                       </a:r>
                     </a:p>
@@ -4573,14 +4591,14 @@
                     <a:p>
                       <a:pPr algn="ctr"/>
                       <a:r>
-                        <a:rPr lang="es-PE" sz="1150" b="0" dirty="0"/>
+                        <a:rPr lang="es-PE" sz="1120" b="0" dirty="0"/>
                         <a:t>MÓDULO</a:t>
                       </a:r>
                       <a:r>
-                        <a:rPr lang="es-PE" sz="1150" b="0" baseline="0" dirty="0"/>
+                        <a:rPr lang="es-PE" sz="1120" b="0" baseline="0" dirty="0"/>
                         <a:t> II</a:t>
                       </a:r>
-                      <a:endParaRPr lang="en-US" sz="1150" b="0" dirty="0"/>
+                      <a:endParaRPr lang="en-US" sz="1120" b="0" dirty="0"/>
                     </a:p>
                   </a:txBody>
                   <a:tcPr anchor="ctr"/>
@@ -4592,7 +4610,7 @@
                     <a:p>
                       <a:pPr algn="ctr"/>
                       <a:r>
-                        <a:rPr lang="es-ES" sz="1150" b="0" i="0" dirty="0"/>
+                        <a:rPr lang="es-ES" sz="1000" b="0" i="0" dirty="0"/>
                         <a:t>{{MODULO_2}}</a:t>
                       </a:r>
                     </a:p>
@@ -4613,14 +4631,14 @@
                     <a:p>
                       <a:pPr algn="ctr"/>
                       <a:r>
-                        <a:rPr lang="es-PE" sz="1150" b="0" dirty="0"/>
+                        <a:rPr lang="es-PE" sz="1120" b="0" dirty="0"/>
                         <a:t>MÓDULO</a:t>
                       </a:r>
                       <a:r>
-                        <a:rPr lang="es-PE" sz="1150" b="0" baseline="0" dirty="0"/>
+                        <a:rPr lang="es-PE" sz="1120" b="0" baseline="0" dirty="0"/>
                         <a:t> III</a:t>
                       </a:r>
-                      <a:endParaRPr lang="en-US" sz="1150" b="0" dirty="0"/>
+                      <a:endParaRPr lang="en-US" sz="1120" b="0" dirty="0"/>
                     </a:p>
                   </a:txBody>
                   <a:tcPr anchor="ctr"/>
@@ -4632,7 +4650,7 @@
                     <a:p>
                       <a:pPr algn="ctr"/>
                       <a:r>
-                        <a:rPr lang="es-PE" sz="1150" b="0" i="0" dirty="0"/>
+                        <a:rPr lang="es-PE" sz="1000" b="0" i="0" dirty="0"/>
                         <a:t>{{MODULO_3}}</a:t>
                       </a:r>
                     </a:p>
@@ -4653,10 +4671,10 @@
                     <a:p>
                       <a:pPr algn="ctr"/>
                       <a:r>
-                        <a:rPr lang="es-PE" sz="1150" b="0" dirty="0"/>
+                        <a:rPr lang="es-PE" sz="1120" b="0" dirty="0"/>
                         <a:t>MÓDULO IV</a:t>
                       </a:r>
-                      <a:endParaRPr lang="en-US" sz="1150" b="0" dirty="0"/>
+                      <a:endParaRPr lang="en-US" sz="1120" b="0" dirty="0"/>
                     </a:p>
                   </a:txBody>
                   <a:tcPr anchor="ctr"/>
@@ -4684,7 +4702,7 @@
                         <a:defRPr/>
                       </a:pPr>
                       <a:r>
-                        <a:rPr lang="es-PE" sz="1150" b="0" i="0" dirty="0"/>
+                        <a:rPr lang="es-PE" sz="1000" b="0" i="0" dirty="0"/>
                         <a:t>{{MODULO_4}}</a:t>
                       </a:r>
                     </a:p>
@@ -4705,14 +4723,14 @@
                     <a:p>
                       <a:pPr algn="ctr"/>
                       <a:r>
-                        <a:rPr lang="es-PE" sz="1150" b="0" dirty="0"/>
+                        <a:rPr lang="es-PE" sz="1120" b="0" dirty="0"/>
                         <a:t>MÓDULO</a:t>
                       </a:r>
                       <a:r>
-                        <a:rPr lang="es-PE" sz="1150" b="0" baseline="0" dirty="0"/>
+                        <a:rPr lang="es-PE" sz="1120" b="0" baseline="0" dirty="0"/>
                         <a:t> V</a:t>
                       </a:r>
-                      <a:endParaRPr lang="en-US" sz="1150" b="0" dirty="0"/>
+                      <a:endParaRPr lang="en-US" sz="1120" b="0" dirty="0"/>
                     </a:p>
                   </a:txBody>
                   <a:tcPr anchor="ctr"/>
@@ -4740,7 +4758,7 @@
                         <a:defRPr/>
                       </a:pPr>
                       <a:r>
-                        <a:rPr lang="es-PE" sz="1150" b="0" i="0" dirty="0"/>
+                        <a:rPr lang="es-PE" sz="1000" b="0" i="0" dirty="0"/>
                         <a:t>{{MODULO_5}}</a:t>
                       </a:r>
                     </a:p>
@@ -4995,10 +5013,10 @@
       </p:pic>
       <p:sp>
         <p:nvSpPr>
-          <p:cNvPr id="3" name="CuadroTexto 1">
+          <p:cNvPr id="4" name="CuadroTexto 1">
             <a:extLst>
               <a:ext uri="{FF2B5EF4-FFF2-40B4-BE49-F238E27FC236}">
-                <a16:creationId xmlns:a16="http://schemas.microsoft.com/office/drawing/2014/main" id="{73FC219E-6E54-02C6-2D68-ED6FE3FBB5EC}"/>
+                <a16:creationId xmlns:a16="http://schemas.microsoft.com/office/drawing/2014/main" id="{C17EA1AD-01FF-52C7-D27A-E9BADDA3B15C}"/>
               </a:ext>
             </a:extLst>
           </p:cNvPr>
@@ -5007,7 +5025,7 @@
         </p:nvSpPr>
         <p:spPr>
           <a:xfrm>
-            <a:off x="1110861" y="4458611"/>
+            <a:off x="1490295" y="4448980"/>
             <a:ext cx="1397690" cy="369332"/>
           </a:xfrm>
           <a:prstGeom prst="rect">
@@ -5116,10 +5134,81 @@
           </a:lstStyle>
           <a:p>
             <a:r>
-              <a:rPr lang="es-PE"/>
+              <a:rPr lang="es-PE" dirty="0"/>
               <a:t>{{QR_CODE}}</a:t>
             </a:r>
-            <a:endParaRPr lang="es-PE" dirty="0"/>
+          </a:p>
+        </p:txBody>
+      </p:sp>
+      <p:sp>
+        <p:nvSpPr>
+          <p:cNvPr id="3" name="Rectángulo 2">
+            <a:extLst>
+              <a:ext uri="{FF2B5EF4-FFF2-40B4-BE49-F238E27FC236}">
+                <a16:creationId xmlns:a16="http://schemas.microsoft.com/office/drawing/2014/main" id="{30F4087D-AFB9-F358-EE89-78E5D8890726}"/>
+              </a:ext>
+            </a:extLst>
+          </p:cNvPr>
+          <p:cNvSpPr/>
+          <p:nvPr/>
+        </p:nvSpPr>
+        <p:spPr>
+          <a:xfrm>
+            <a:off x="684240" y="5727842"/>
+            <a:ext cx="2130198" cy="366767"/>
+          </a:xfrm>
+          <a:prstGeom prst="rect">
+            <a:avLst/>
+          </a:prstGeom>
+        </p:spPr>
+        <p:txBody>
+          <a:bodyPr wrap="square">
+            <a:spAutoFit/>
+          </a:bodyPr>
+          <a:lstStyle/>
+          <a:p>
+            <a:pPr lvl="0" algn="ctr">
+              <a:spcBef>
+                <a:spcPts val="59"/>
+              </a:spcBef>
+            </a:pPr>
+            <a:r>
+              <a:rPr lang="es-PE" sz="900" dirty="0">
+                <a:solidFill>
+                  <a:prstClr val="black"/>
+                </a:solidFill>
+                <a:latin typeface="Times New Roman" panose="02020603050405020304" pitchFamily="18" charset="0"/>
+                <a:ea typeface="Cambria Math" panose="02040503050406030204" pitchFamily="18" charset="0"/>
+                <a:cs typeface="Times New Roman" panose="02020603050405020304" pitchFamily="18" charset="0"/>
+              </a:rPr>
+              <a:t>CÓDIGO ESTUDIANTE:</a:t>
+            </a:r>
+          </a:p>
+          <a:p>
+            <a:pPr algn="ctr">
+              <a:spcBef>
+                <a:spcPts val="59"/>
+              </a:spcBef>
+            </a:pPr>
+            <a:r>
+              <a:rPr lang="en-US" sz="800" b="1">
+                <a:solidFill>
+                  <a:prstClr val="black"/>
+                </a:solidFill>
+                <a:latin typeface="Times New Roman" panose="02020603050405020304" pitchFamily="18" charset="0"/>
+                <a:ea typeface="Cambria Math" panose="02040503050406030204" pitchFamily="18" charset="0"/>
+                <a:cs typeface="Times New Roman" panose="02020603050405020304" pitchFamily="18" charset="0"/>
+              </a:rPr>
+              <a:t>{{CODE_STUDENT}}</a:t>
+            </a:r>
+            <a:endParaRPr lang="en-US" sz="800" b="1" dirty="0">
+              <a:solidFill>
+                <a:prstClr val="black"/>
+              </a:solidFill>
+              <a:latin typeface="Times New Roman" panose="02020603050405020304" pitchFamily="18" charset="0"/>
+              <a:ea typeface="Cambria Math" panose="02040503050406030204" pitchFamily="18" charset="0"/>
+              <a:cs typeface="Times New Roman" panose="02020603050405020304" pitchFamily="18" charset="0"/>
+            </a:endParaRPr>
           </a:p>
         </p:txBody>
       </p:sp>

</xml_diff>